<commit_message>
Improve Id slide contrast
</commit_message>
<xml_diff>
--- a/assets/presentations/2026-05-17-id.pptx
+++ b/assets/presentations/2026-05-17-id.pptx
@@ -2,15 +2,15 @@
 <file path=ppt/presentation.xml><?xml version="1.0" encoding="utf-8"?>
 <p:presentation xmlns:p="http://schemas.openxmlformats.org/presentationml/2006/main">
   <p:sldMasterIdLst>
-    <p:sldMasterId xmlns:r="http://schemas.openxmlformats.org/officeDocument/2006/relationships" id="2147483648" r:id="R7f620aeef4834cf7"/>
+    <p:sldMasterId xmlns:r="http://schemas.openxmlformats.org/officeDocument/2006/relationships" id="2147483648" r:id="Ree9f916be6cf461c"/>
   </p:sldMasterIdLst>
   <p:notesMasterIdLst>
-    <p:notesMasterId xmlns:r="http://schemas.openxmlformats.org/officeDocument/2006/relationships" r:id="R27f6ed9d2c1548d4"/>
+    <p:notesMasterId xmlns:r="http://schemas.openxmlformats.org/officeDocument/2006/relationships" r:id="R2018e4760d03426b"/>
   </p:notesMasterIdLst>
   <p:sldIdLst>
-    <p:sldId xmlns:r="http://schemas.openxmlformats.org/officeDocument/2006/relationships" id="256" r:id="Rcfb7a1cf585149c0"/>
-    <p:sldId xmlns:r="http://schemas.openxmlformats.org/officeDocument/2006/relationships" id="257" r:id="R37c827bd21d146c9"/>
-    <p:sldId xmlns:r="http://schemas.openxmlformats.org/officeDocument/2006/relationships" id="258" r:id="Rf501d35bdcd7411e"/>
+    <p:sldId xmlns:r="http://schemas.openxmlformats.org/officeDocument/2006/relationships" id="256" r:id="R363e19d6bb944cca"/>
+    <p:sldId xmlns:r="http://schemas.openxmlformats.org/officeDocument/2006/relationships" id="257" r:id="R13213ddf3a5f4823"/>
+    <p:sldId xmlns:r="http://schemas.openxmlformats.org/officeDocument/2006/relationships" id="258" r:id="Rff2a2d4fe7c7450b"/>
   </p:sldIdLst>
   <p:sldSz cx="12192000" cy="6858000"/>
   <p:notesSz cx="6858000" cy="9144000"/>
@@ -747,7 +747,7 @@
   </p:cSld>
   <p:clrMap bg1="lt1" tx1="dk1" bg2="lt2" tx2="dk2" accent1="accent1" accent2="accent2" accent3="accent3" accent4="accent4" accent5="accent5" accent6="accent6" hlink="hlink" folHlink="folHlink"/>
   <p:sldLayoutIdLst>
-    <p:sldLayoutId xmlns:r="http://schemas.openxmlformats.org/officeDocument/2006/relationships" id="2147483649" r:id="R72cbe418e73c4b9f"/>
+    <p:sldLayoutId xmlns:r="http://schemas.openxmlformats.org/officeDocument/2006/relationships" id="2147483649" r:id="R3544a8d032e64102"/>
   </p:sldLayoutIdLst>
   <p:txStyles>
     <p:titleStyle>
@@ -1295,7 +1295,7 @@
           <p:nvPr/>
         </p:nvPicPr>
         <p:blipFill>
-          <a:blip xmlns:r="http://schemas.openxmlformats.org/officeDocument/2006/relationships" xmlns:a="http://schemas.openxmlformats.org/drawingml/2006/main" r:embed="Rabd4f58062aa4bc1"/>
+          <a:blip xmlns:r="http://schemas.openxmlformats.org/officeDocument/2006/relationships" xmlns:a="http://schemas.openxmlformats.org/drawingml/2006/main" r:embed="Re9526fb4acd9421a"/>
           <a:srcRect xmlns:a="http://schemas.openxmlformats.org/drawingml/2006/main" l="0" t="27" r="0" b="27"/>
           <a:stretch xmlns:a="http://schemas.openxmlformats.org/drawingml/2006/main">
             <a:fillRect l="0" t="0" r="0" b="0"/>
@@ -1540,7 +1540,7 @@
               <a:rPr sz="1875">
                 <a:ln w="0"/>
                 <a:solidFill>
-                  <a:srgbClr val="F5E7C3"/>
+                  <a:srgbClr val="FF9A3C"/>
                 </a:solidFill>
                 <a:effectLst>
                   <a:outerShdw blurRad="38100" dist="19050" dir="2700000" algn="tl" rotWithShape="0">
@@ -1566,7 +1566,7 @@
               <a:rPr sz="1875">
                 <a:ln w="0"/>
                 <a:solidFill>
-                  <a:srgbClr val="F5E7C3"/>
+                  <a:srgbClr val="FF9A3C"/>
                 </a:solidFill>
                 <a:effectLst>
                   <a:outerShdw blurRad="38100" dist="19050" dir="2700000" algn="tl" rotWithShape="0">
@@ -1624,7 +1624,7 @@
               <a:rPr sz="1200">
                 <a:ln w="0"/>
                 <a:solidFill>
-                  <a:srgbClr val="FFFFFF"/>
+                  <a:srgbClr val="FF9A3C"/>
                 </a:solidFill>
                 <a:effectLst>
                   <a:outerShdw blurRad="38100" dist="19050" dir="2700000" algn="tl" rotWithShape="0">
@@ -1650,7 +1650,7 @@
               <a:rPr sz="1200">
                 <a:ln w="0"/>
                 <a:solidFill>
-                  <a:srgbClr val="FFFFFF"/>
+                  <a:srgbClr val="FF9A3C"/>
                 </a:solidFill>
                 <a:effectLst>
                   <a:outerShdw blurRad="38100" dist="19050" dir="2700000" algn="tl" rotWithShape="0">
@@ -3238,13 +3238,7 @@
               </a:rPr>
               <a:t>«Id… no para gritar más fuerte,</a:t>
             </a:r>
-            <a:br>
-              <a:rPr sz="1350" b="1">
-                <a:solidFill>
-                  <a:srgbClr val="F5E7C3"/>
-                </a:solidFill>
-              </a:rPr>
-            </a:br>
+            <a:br/>
             <a:r>
               <a:rPr sz="1350" b="1">
                 <a:solidFill>

</xml_diff>

<commit_message>
Improve Id slide contrast (#25)
</commit_message>
<xml_diff>
--- a/assets/presentations/2026-05-17-id.pptx
+++ b/assets/presentations/2026-05-17-id.pptx
@@ -2,15 +2,15 @@
 <file path=ppt/presentation.xml><?xml version="1.0" encoding="utf-8"?>
 <p:presentation xmlns:p="http://schemas.openxmlformats.org/presentationml/2006/main">
   <p:sldMasterIdLst>
-    <p:sldMasterId xmlns:r="http://schemas.openxmlformats.org/officeDocument/2006/relationships" id="2147483648" r:id="R7f620aeef4834cf7"/>
+    <p:sldMasterId xmlns:r="http://schemas.openxmlformats.org/officeDocument/2006/relationships" id="2147483648" r:id="Ree9f916be6cf461c"/>
   </p:sldMasterIdLst>
   <p:notesMasterIdLst>
-    <p:notesMasterId xmlns:r="http://schemas.openxmlformats.org/officeDocument/2006/relationships" r:id="R27f6ed9d2c1548d4"/>
+    <p:notesMasterId xmlns:r="http://schemas.openxmlformats.org/officeDocument/2006/relationships" r:id="R2018e4760d03426b"/>
   </p:notesMasterIdLst>
   <p:sldIdLst>
-    <p:sldId xmlns:r="http://schemas.openxmlformats.org/officeDocument/2006/relationships" id="256" r:id="Rcfb7a1cf585149c0"/>
-    <p:sldId xmlns:r="http://schemas.openxmlformats.org/officeDocument/2006/relationships" id="257" r:id="R37c827bd21d146c9"/>
-    <p:sldId xmlns:r="http://schemas.openxmlformats.org/officeDocument/2006/relationships" id="258" r:id="Rf501d35bdcd7411e"/>
+    <p:sldId xmlns:r="http://schemas.openxmlformats.org/officeDocument/2006/relationships" id="256" r:id="R363e19d6bb944cca"/>
+    <p:sldId xmlns:r="http://schemas.openxmlformats.org/officeDocument/2006/relationships" id="257" r:id="R13213ddf3a5f4823"/>
+    <p:sldId xmlns:r="http://schemas.openxmlformats.org/officeDocument/2006/relationships" id="258" r:id="Rff2a2d4fe7c7450b"/>
   </p:sldIdLst>
   <p:sldSz cx="12192000" cy="6858000"/>
   <p:notesSz cx="6858000" cy="9144000"/>
@@ -747,7 +747,7 @@
   </p:cSld>
   <p:clrMap bg1="lt1" tx1="dk1" bg2="lt2" tx2="dk2" accent1="accent1" accent2="accent2" accent3="accent3" accent4="accent4" accent5="accent5" accent6="accent6" hlink="hlink" folHlink="folHlink"/>
   <p:sldLayoutIdLst>
-    <p:sldLayoutId xmlns:r="http://schemas.openxmlformats.org/officeDocument/2006/relationships" id="2147483649" r:id="R72cbe418e73c4b9f"/>
+    <p:sldLayoutId xmlns:r="http://schemas.openxmlformats.org/officeDocument/2006/relationships" id="2147483649" r:id="R3544a8d032e64102"/>
   </p:sldLayoutIdLst>
   <p:txStyles>
     <p:titleStyle>
@@ -1295,7 +1295,7 @@
           <p:nvPr/>
         </p:nvPicPr>
         <p:blipFill>
-          <a:blip xmlns:r="http://schemas.openxmlformats.org/officeDocument/2006/relationships" xmlns:a="http://schemas.openxmlformats.org/drawingml/2006/main" r:embed="Rabd4f58062aa4bc1"/>
+          <a:blip xmlns:r="http://schemas.openxmlformats.org/officeDocument/2006/relationships" xmlns:a="http://schemas.openxmlformats.org/drawingml/2006/main" r:embed="Re9526fb4acd9421a"/>
           <a:srcRect xmlns:a="http://schemas.openxmlformats.org/drawingml/2006/main" l="0" t="27" r="0" b="27"/>
           <a:stretch xmlns:a="http://schemas.openxmlformats.org/drawingml/2006/main">
             <a:fillRect l="0" t="0" r="0" b="0"/>
@@ -1540,7 +1540,7 @@
               <a:rPr sz="1875">
                 <a:ln w="0"/>
                 <a:solidFill>
-                  <a:srgbClr val="F5E7C3"/>
+                  <a:srgbClr val="FF9A3C"/>
                 </a:solidFill>
                 <a:effectLst>
                   <a:outerShdw blurRad="38100" dist="19050" dir="2700000" algn="tl" rotWithShape="0">
@@ -1566,7 +1566,7 @@
               <a:rPr sz="1875">
                 <a:ln w="0"/>
                 <a:solidFill>
-                  <a:srgbClr val="F5E7C3"/>
+                  <a:srgbClr val="FF9A3C"/>
                 </a:solidFill>
                 <a:effectLst>
                   <a:outerShdw blurRad="38100" dist="19050" dir="2700000" algn="tl" rotWithShape="0">
@@ -1624,7 +1624,7 @@
               <a:rPr sz="1200">
                 <a:ln w="0"/>
                 <a:solidFill>
-                  <a:srgbClr val="FFFFFF"/>
+                  <a:srgbClr val="FF9A3C"/>
                 </a:solidFill>
                 <a:effectLst>
                   <a:outerShdw blurRad="38100" dist="19050" dir="2700000" algn="tl" rotWithShape="0">
@@ -1650,7 +1650,7 @@
               <a:rPr sz="1200">
                 <a:ln w="0"/>
                 <a:solidFill>
-                  <a:srgbClr val="FFFFFF"/>
+                  <a:srgbClr val="FF9A3C"/>
                 </a:solidFill>
                 <a:effectLst>
                   <a:outerShdw blurRad="38100" dist="19050" dir="2700000" algn="tl" rotWithShape="0">
@@ -3238,13 +3238,7 @@
               </a:rPr>
               <a:t>«Id… no para gritar más fuerte,</a:t>
             </a:r>
-            <a:br>
-              <a:rPr sz="1350" b="1">
-                <a:solidFill>
-                  <a:srgbClr val="F5E7C3"/>
-                </a:solidFill>
-              </a:rPr>
-            </a:br>
+            <a:br/>
             <a:r>
               <a:rPr sz="1350" b="1">
                 <a:solidFill>

</xml_diff>

<commit_message>
Corrige la identidad visual de Jesús en Id
</commit_message>
<xml_diff>
--- a/assets/presentations/2026-05-17-id.pptx
+++ b/assets/presentations/2026-05-17-id.pptx
@@ -2,15 +2,15 @@
 <file path=ppt/presentation.xml><?xml version="1.0" encoding="utf-8"?>
 <p:presentation xmlns:p="http://schemas.openxmlformats.org/presentationml/2006/main">
   <p:sldMasterIdLst>
-    <p:sldMasterId xmlns:r="http://schemas.openxmlformats.org/officeDocument/2006/relationships" id="2147483648" r:id="Ree9f916be6cf461c"/>
+    <p:sldMasterId xmlns:r="http://schemas.openxmlformats.org/officeDocument/2006/relationships" id="2147483648" r:id="R914ab7f4584f4263"/>
   </p:sldMasterIdLst>
   <p:notesMasterIdLst>
-    <p:notesMasterId xmlns:r="http://schemas.openxmlformats.org/officeDocument/2006/relationships" r:id="R2018e4760d03426b"/>
+    <p:notesMasterId xmlns:r="http://schemas.openxmlformats.org/officeDocument/2006/relationships" r:id="Rd5177ce55a1a4058"/>
   </p:notesMasterIdLst>
   <p:sldIdLst>
-    <p:sldId xmlns:r="http://schemas.openxmlformats.org/officeDocument/2006/relationships" id="256" r:id="R363e19d6bb944cca"/>
-    <p:sldId xmlns:r="http://schemas.openxmlformats.org/officeDocument/2006/relationships" id="257" r:id="R13213ddf3a5f4823"/>
-    <p:sldId xmlns:r="http://schemas.openxmlformats.org/officeDocument/2006/relationships" id="258" r:id="Rff2a2d4fe7c7450b"/>
+    <p:sldId xmlns:r="http://schemas.openxmlformats.org/officeDocument/2006/relationships" id="256" r:id="Rb854e886ad1b4325"/>
+    <p:sldId xmlns:r="http://schemas.openxmlformats.org/officeDocument/2006/relationships" id="257" r:id="R23c0ffda16e0429d"/>
+    <p:sldId xmlns:r="http://schemas.openxmlformats.org/officeDocument/2006/relationships" id="258" r:id="R8a62b5dd4f2b414e"/>
   </p:sldIdLst>
   <p:sldSz cx="12192000" cy="6858000"/>
   <p:notesSz cx="6858000" cy="9144000"/>
@@ -747,7 +747,7 @@
   </p:cSld>
   <p:clrMap bg1="lt1" tx1="dk1" bg2="lt2" tx2="dk2" accent1="accent1" accent2="accent2" accent3="accent3" accent4="accent4" accent5="accent5" accent6="accent6" hlink="hlink" folHlink="folHlink"/>
   <p:sldLayoutIdLst>
-    <p:sldLayoutId xmlns:r="http://schemas.openxmlformats.org/officeDocument/2006/relationships" id="2147483649" r:id="R3544a8d032e64102"/>
+    <p:sldLayoutId xmlns:r="http://schemas.openxmlformats.org/officeDocument/2006/relationships" id="2147483649" r:id="Rdf88eb50d8014793"/>
   </p:sldLayoutIdLst>
   <p:txStyles>
     <p:titleStyle>
@@ -1295,14 +1295,14 @@
           <p:nvPr/>
         </p:nvPicPr>
         <p:blipFill>
-          <a:blip xmlns:r="http://schemas.openxmlformats.org/officeDocument/2006/relationships" xmlns:a="http://schemas.openxmlformats.org/drawingml/2006/main" r:embed="Re9526fb4acd9421a"/>
+          <a:blip xmlns:r="http://schemas.openxmlformats.org/officeDocument/2006/relationships" xmlns:a="http://schemas.openxmlformats.org/drawingml/2006/main" r:embed="Rf8f822d7911b44d2"/>
           <a:srcRect xmlns:a="http://schemas.openxmlformats.org/drawingml/2006/main" l="0" t="27" r="0" b="27"/>
           <a:stretch xmlns:a="http://schemas.openxmlformats.org/drawingml/2006/main">
             <a:fillRect l="0" t="0" r="0" b="0"/>
           </a:stretch>
         </p:blipFill>
         <p:spPr>
-          <a:xfrm xmlns:a="http://schemas.openxmlformats.org/drawingml/2006/main">
+          <a:xfrm xmlns:a="http://schemas.openxmlformats.org/drawingml/2006/main" flipH="0" flipV="0">
             <a:off x="0" y="0"/>
             <a:ext cx="12192000" cy="6858000"/>
           </a:xfrm>

</xml_diff>

<commit_message>
Corrige la identidad visual de Jesús en Id (#33)
</commit_message>
<xml_diff>
--- a/assets/presentations/2026-05-17-id.pptx
+++ b/assets/presentations/2026-05-17-id.pptx
@@ -2,15 +2,15 @@
 <file path=ppt/presentation.xml><?xml version="1.0" encoding="utf-8"?>
 <p:presentation xmlns:p="http://schemas.openxmlformats.org/presentationml/2006/main">
   <p:sldMasterIdLst>
-    <p:sldMasterId xmlns:r="http://schemas.openxmlformats.org/officeDocument/2006/relationships" id="2147483648" r:id="Ree9f916be6cf461c"/>
+    <p:sldMasterId xmlns:r="http://schemas.openxmlformats.org/officeDocument/2006/relationships" id="2147483648" r:id="R914ab7f4584f4263"/>
   </p:sldMasterIdLst>
   <p:notesMasterIdLst>
-    <p:notesMasterId xmlns:r="http://schemas.openxmlformats.org/officeDocument/2006/relationships" r:id="R2018e4760d03426b"/>
+    <p:notesMasterId xmlns:r="http://schemas.openxmlformats.org/officeDocument/2006/relationships" r:id="Rd5177ce55a1a4058"/>
   </p:notesMasterIdLst>
   <p:sldIdLst>
-    <p:sldId xmlns:r="http://schemas.openxmlformats.org/officeDocument/2006/relationships" id="256" r:id="R363e19d6bb944cca"/>
-    <p:sldId xmlns:r="http://schemas.openxmlformats.org/officeDocument/2006/relationships" id="257" r:id="R13213ddf3a5f4823"/>
-    <p:sldId xmlns:r="http://schemas.openxmlformats.org/officeDocument/2006/relationships" id="258" r:id="Rff2a2d4fe7c7450b"/>
+    <p:sldId xmlns:r="http://schemas.openxmlformats.org/officeDocument/2006/relationships" id="256" r:id="Rb854e886ad1b4325"/>
+    <p:sldId xmlns:r="http://schemas.openxmlformats.org/officeDocument/2006/relationships" id="257" r:id="R23c0ffda16e0429d"/>
+    <p:sldId xmlns:r="http://schemas.openxmlformats.org/officeDocument/2006/relationships" id="258" r:id="R8a62b5dd4f2b414e"/>
   </p:sldIdLst>
   <p:sldSz cx="12192000" cy="6858000"/>
   <p:notesSz cx="6858000" cy="9144000"/>
@@ -747,7 +747,7 @@
   </p:cSld>
   <p:clrMap bg1="lt1" tx1="dk1" bg2="lt2" tx2="dk2" accent1="accent1" accent2="accent2" accent3="accent3" accent4="accent4" accent5="accent5" accent6="accent6" hlink="hlink" folHlink="folHlink"/>
   <p:sldLayoutIdLst>
-    <p:sldLayoutId xmlns:r="http://schemas.openxmlformats.org/officeDocument/2006/relationships" id="2147483649" r:id="R3544a8d032e64102"/>
+    <p:sldLayoutId xmlns:r="http://schemas.openxmlformats.org/officeDocument/2006/relationships" id="2147483649" r:id="Rdf88eb50d8014793"/>
   </p:sldLayoutIdLst>
   <p:txStyles>
     <p:titleStyle>
@@ -1295,14 +1295,14 @@
           <p:nvPr/>
         </p:nvPicPr>
         <p:blipFill>
-          <a:blip xmlns:r="http://schemas.openxmlformats.org/officeDocument/2006/relationships" xmlns:a="http://schemas.openxmlformats.org/drawingml/2006/main" r:embed="Re9526fb4acd9421a"/>
+          <a:blip xmlns:r="http://schemas.openxmlformats.org/officeDocument/2006/relationships" xmlns:a="http://schemas.openxmlformats.org/drawingml/2006/main" r:embed="Rf8f822d7911b44d2"/>
           <a:srcRect xmlns:a="http://schemas.openxmlformats.org/drawingml/2006/main" l="0" t="27" r="0" b="27"/>
           <a:stretch xmlns:a="http://schemas.openxmlformats.org/drawingml/2006/main">
             <a:fillRect l="0" t="0" r="0" b="0"/>
           </a:stretch>
         </p:blipFill>
         <p:spPr>
-          <a:xfrm xmlns:a="http://schemas.openxmlformats.org/drawingml/2006/main">
+          <a:xfrm xmlns:a="http://schemas.openxmlformats.org/drawingml/2006/main" flipH="0" flipV="0">
             <a:off x="0" y="0"/>
             <a:ext cx="12192000" cy="6858000"/>
           </a:xfrm>

</xml_diff>